<commit_message>
Presentations: Business and Compliance (DE/RO) brought up to date from one source file
Co-Authored-By: Claude Sonnet 5.5 <noreply@anthropic.com>
Claude-Session: https://claude.ai/code/session_01B6MtnqXxmaSfAE7RzqzhBD
</commit_message>
<xml_diff>
--- a/unpruuf/presentations/export/unpruuf_Business_DE.pptx
+++ b/unpruuf/presentations/export/unpruuf_Business_DE.pptx
@@ -19,8 +19,11 @@
     <p:sldId id="267" r:id="rId19"/>
     <p:sldId id="268" r:id="rId20"/>
     <p:sldId id="269" r:id="rId21"/>
+    <p:sldId id="270" r:id="rId22"/>
+    <p:sldId id="271" r:id="rId23"/>
+    <p:sldId id="272" r:id="rId24"/>
   </p:sldIdLst>
-  <p:sldSz cx="12192000" cy="6858000" type="screen4x3"/>
+  <p:sldSz cx="12191695" cy="6858000" type="screen4x3"/>
   <p:notesSz cx="6858000" cy="9144000"/>
   <p:defaultTextStyle>
     <a:defPPr>
@@ -515,7 +518,7 @@
           <a:lstStyle/>
           <a:p>
             <a:r>
-              <a:t>Kernbotschaft: Wir verkaufen keinen Messenger-Dienst. Wir bauen dem Kunden sein eigenes Kommunikationssystem, das NexonAI nicht betreibt.</a:t>
+              <a:t>Kernbotschaft: Wir verkaufen keinen Messenger-Dienst. Wir liefern dem Kunden sein eigenes Kommunikationssystem. NexonAI betreibt keine Server, die Server gehören immer dem Kunden.</a:t>
             </a:r>
           </a:p>
         </p:txBody>
@@ -585,7 +588,7 @@
           <a:lstStyle/>
           <a:p>
             <a:r>
-              <a:t>Der Server ist das Werkzeug: Damit baut sich jeder Nutzer sein eigenes anonymes Kommunikationssystem. NexonAI hostet nichts.</a:t>
+              <a:t>Der Server ist das Werkzeug: Damit baut sich jeder Kunde sein eigenes Kommunikationssystem. Er erzeugt immer die volle lizenzierte Zahl an Adressen, höchstens 250. NexonAI hostet nichts.</a:t>
             </a:r>
           </a:p>
         </p:txBody>
@@ -655,7 +658,7 @@
           <a:lstStyle/>
           <a:p>
             <a:r>
-              <a:t>A schreibt auf seine eigenen Nodes, B holt dort ab. Der Rückweg läuft über die Nodes von B. Niemand schreibt auf fremde Nodes.</a:t>
+              <a:t>Jede Nachricht geht an alle drei Nodes des Kontakts, auf drei verschiedenen Servern. Fällt einer oder fallen sogar zwei aus, ist die Nachricht noch da. Der Kontakt prüft alle drei. Der Rückweg läuft über die Nodes des Kontakts.</a:t>
             </a:r>
           </a:p>
         </p:txBody>
@@ -725,7 +728,7 @@
           <a:lstStyle/>
           <a:p>
             <a:r>
-              <a:t>Gemessen ohne Live-Tor-Netz: 500 Nodes in einem Prozess rund 85 MB RAM. Die Netzlast auf einem echten VPS wird noch gemessen.</a:t>
+              <a:t>Gemessen ohne Live-Tor-Netz: 500 Nodes in einem Prozess rund 85 MB RAM. Die Netzlast auf einem echten VPS ist noch nicht gemessen. 250 Kontakte gilt bei drei Servern mit je 250 Nodes, weil jeder Kontakt einen Node je Server bekommt.</a:t>
             </a:r>
           </a:p>
         </p:txBody>
@@ -795,7 +798,217 @@
           <a:lstStyle/>
           <a:p>
             <a:r>
-              <a:t>Vorsichtig formulieren: Wir sagen nicht, dass Durchsuchungen oder Anordnungen sinnlos sind. Wir sagen, dass es keinen Anbieter gibt, der etwas herausgeben könnte, und dass ein beschlagnahmter Node nichts Lesbares enthält.</a:t>
+              <a:t>Die Empfehlung drei Anbieter, zwei Länder ist Sache des Kunden: Die App kann nicht prüfen, ob drei Server beim selben Hoster liegen. Nach einem Neustart ist jeder Server gesperrt, bis die App ihn freigibt. Solange einer gesperrt ist, tragen die anderen.</a:t>
+            </a:r>
+          </a:p>
+        </p:txBody>
+      </p:sp>
+      <p:sp>
+        <p:nvSpPr>
+          <p:cNvPr id="4" name="Slide Number Placeholder 3"/>
+          <p:cNvSpPr>
+            <a:spLocks noGrp="1"/>
+          </p:cNvSpPr>
+          <p:nvPr>
+            <p:ph type="sldNum" idx="5" sz="quarter"/>
+          </p:nvPr>
+        </p:nvSpPr>
+        <p:spPr/>
+      </p:sp>
+    </p:spTree>
+  </p:cSld>
+  <p:clrMapOvr>
+    <a:masterClrMapping/>
+  </p:clrMapOvr>
+</p:notes>
+</file>
+
+<file path=ppt/notesSlides/notesSlide6.xml><?xml version="1.0" encoding="utf-8"?>
+<p:notes xmlns:a="http://schemas.openxmlformats.org/drawingml/2006/main" xmlns:p="http://schemas.openxmlformats.org/presentationml/2006/main" xmlns:r="http://schemas.openxmlformats.org/officeDocument/2006/relationships">
+  <p:cSld>
+    <p:spTree>
+      <p:nvGrpSpPr>
+        <p:cNvPr id="1" name=""/>
+        <p:cNvGrpSpPr/>
+        <p:nvPr/>
+      </p:nvGrpSpPr>
+      <p:grpSpPr>
+        <a:xfrm>
+          <a:off x="0" y="0"/>
+          <a:ext cx="0" cy="0"/>
+          <a:chOff x="0" y="0"/>
+          <a:chExt cx="0" cy="0"/>
+        </a:xfrm>
+      </p:grpSpPr>
+      <p:sp>
+        <p:nvSpPr>
+          <p:cNvPr id="2" name="Slide Image Placeholder 1"/>
+          <p:cNvSpPr>
+            <a:spLocks noGrp="1"/>
+          </p:cNvSpPr>
+          <p:nvPr>
+            <p:ph type="sldImg" idx="2"/>
+          </p:nvPr>
+        </p:nvSpPr>
+        <p:spPr/>
+      </p:sp>
+      <p:sp>
+        <p:nvSpPr>
+          <p:cNvPr id="3" name="Notes Placeholder 2"/>
+          <p:cNvSpPr>
+            <a:spLocks noGrp="1"/>
+          </p:cNvSpPr>
+          <p:nvPr>
+            <p:ph type="body" idx="3" sz="quarter"/>
+          </p:nvPr>
+        </p:nvSpPr>
+        <p:spPr/>
+        <p:txBody>
+          <a:bodyPr/>
+          <a:lstStyle/>
+          <a:p>
+            <a:r>
+              <a:t>Eine Liste mit nur einem Server legt alle drei Nodes eines Kontakts auf dieselbe Maschine. Deshalb mehrere Server in eine Liste legen.</a:t>
+            </a:r>
+          </a:p>
+        </p:txBody>
+      </p:sp>
+      <p:sp>
+        <p:nvSpPr>
+          <p:cNvPr id="4" name="Slide Number Placeholder 3"/>
+          <p:cNvSpPr>
+            <a:spLocks noGrp="1"/>
+          </p:cNvSpPr>
+          <p:nvPr>
+            <p:ph type="sldNum" idx="5" sz="quarter"/>
+          </p:nvPr>
+        </p:nvSpPr>
+        <p:spPr/>
+      </p:sp>
+    </p:spTree>
+  </p:cSld>
+  <p:clrMapOvr>
+    <a:masterClrMapping/>
+  </p:clrMapOvr>
+</p:notes>
+</file>
+
+<file path=ppt/notesSlides/notesSlide7.xml><?xml version="1.0" encoding="utf-8"?>
+<p:notes xmlns:a="http://schemas.openxmlformats.org/drawingml/2006/main" xmlns:p="http://schemas.openxmlformats.org/presentationml/2006/main" xmlns:r="http://schemas.openxmlformats.org/officeDocument/2006/relationships">
+  <p:cSld>
+    <p:spTree>
+      <p:nvGrpSpPr>
+        <p:cNvPr id="1" name=""/>
+        <p:cNvGrpSpPr/>
+        <p:nvPr/>
+      </p:nvGrpSpPr>
+      <p:grpSpPr>
+        <a:xfrm>
+          <a:off x="0" y="0"/>
+          <a:ext cx="0" cy="0"/>
+          <a:chOff x="0" y="0"/>
+          <a:chExt cx="0" cy="0"/>
+        </a:xfrm>
+      </p:grpSpPr>
+      <p:sp>
+        <p:nvSpPr>
+          <p:cNvPr id="2" name="Slide Image Placeholder 1"/>
+          <p:cNvSpPr>
+            <a:spLocks noGrp="1"/>
+          </p:cNvSpPr>
+          <p:nvPr>
+            <p:ph type="sldImg" idx="2"/>
+          </p:nvPr>
+        </p:nvSpPr>
+        <p:spPr/>
+      </p:sp>
+      <p:sp>
+        <p:nvSpPr>
+          <p:cNvPr id="3" name="Notes Placeholder 2"/>
+          <p:cNvSpPr>
+            <a:spLocks noGrp="1"/>
+          </p:cNvSpPr>
+          <p:nvPr>
+            <p:ph type="body" idx="3" sz="quarter"/>
+          </p:nvPr>
+        </p:nvSpPr>
+        <p:spPr/>
+        <p:txBody>
+          <a:bodyPr/>
+          <a:lstStyle/>
+          <a:p>
+            <a:r>
+              <a:t>Vorsichtig formulieren: Wir sagen nicht, dass Durchsuchungen oder Anordnungen sinnlos sind. Wir sagen, dass es keinen Anbieter gibt, der etwas herausgeben könnte, und dass ein beschlagnahmter Node nichts Lesbares enthält. Rechtliche Einschätzung durch einen Anwalt bestätigen lassen.</a:t>
+            </a:r>
+          </a:p>
+        </p:txBody>
+      </p:sp>
+      <p:sp>
+        <p:nvSpPr>
+          <p:cNvPr id="4" name="Slide Number Placeholder 3"/>
+          <p:cNvSpPr>
+            <a:spLocks noGrp="1"/>
+          </p:cNvSpPr>
+          <p:nvPr>
+            <p:ph type="sldNum" idx="5" sz="quarter"/>
+          </p:nvPr>
+        </p:nvSpPr>
+        <p:spPr/>
+      </p:sp>
+    </p:spTree>
+  </p:cSld>
+  <p:clrMapOvr>
+    <a:masterClrMapping/>
+  </p:clrMapOvr>
+</p:notes>
+</file>
+
+<file path=ppt/notesSlides/notesSlide8.xml><?xml version="1.0" encoding="utf-8"?>
+<p:notes xmlns:a="http://schemas.openxmlformats.org/drawingml/2006/main" xmlns:p="http://schemas.openxmlformats.org/presentationml/2006/main" xmlns:r="http://schemas.openxmlformats.org/officeDocument/2006/relationships">
+  <p:cSld>
+    <p:spTree>
+      <p:nvGrpSpPr>
+        <p:cNvPr id="1" name=""/>
+        <p:cNvGrpSpPr/>
+        <p:nvPr/>
+      </p:nvGrpSpPr>
+      <p:grpSpPr>
+        <a:xfrm>
+          <a:off x="0" y="0"/>
+          <a:ext cx="0" cy="0"/>
+          <a:chOff x="0" y="0"/>
+          <a:chExt cx="0" cy="0"/>
+        </a:xfrm>
+      </p:grpSpPr>
+      <p:sp>
+        <p:nvSpPr>
+          <p:cNvPr id="2" name="Slide Image Placeholder 1"/>
+          <p:cNvSpPr>
+            <a:spLocks noGrp="1"/>
+          </p:cNvSpPr>
+          <p:nvPr>
+            <p:ph type="sldImg" idx="2"/>
+          </p:nvPr>
+        </p:nvSpPr>
+        <p:spPr/>
+      </p:sp>
+      <p:sp>
+        <p:nvSpPr>
+          <p:cNvPr id="3" name="Notes Placeholder 2"/>
+          <p:cNvSpPr>
+            <a:spLocks noGrp="1"/>
+          </p:cNvSpPr>
+          <p:nvPr>
+            <p:ph type="body" idx="3" sz="quarter"/>
+          </p:nvPr>
+        </p:nvSpPr>
+        <p:spPr/>
+        <p:txBody>
+          <a:bodyPr/>
+          <a:lstStyle/>
+          <a:p>
+            <a:r>
+              <a:t>Die Staffeln 5, 25, 100, 250 sind geplant, die Preise sind offen. Für den Kunden zählt die Zahl der Kontakte mit eigenen Adressen, nicht die der Nodes. Ein Code lässt sich technisch auf mehreren Servern starten, die Begrenzung auf einen Server steht im Vertrag.</a:t>
             </a:r>
           </a:p>
         </p:txBody>
@@ -3818,7 +4031,7 @@
         <p:spPr>
           <a:xfrm>
             <a:off x="0" y="0"/>
-            <a:ext cx="12192000" cy="6858000"/>
+            <a:ext cx="12191695" cy="6858000"/>
           </a:xfrm>
           <a:prstGeom prst="rect">
             <a:avLst/>
@@ -3845,7 +4058,7 @@
       <p:grpSpPr/>
       <p:pic>
         <p:nvPicPr>
-          <p:cNvPr id="2" name="Picture 1" descr="10-securitate.png"/>
+          <p:cNvPr id="2" name="Picture 1" descr="10-ce-vede.png"/>
           <p:cNvPicPr>
             <a:picLocks noChangeAspect="1"/>
           </p:cNvPicPr>
@@ -3860,7 +4073,7 @@
         <p:spPr>
           <a:xfrm>
             <a:off x="0" y="0"/>
-            <a:ext cx="12192000" cy="6858000"/>
+            <a:ext cx="12191695" cy="6858000"/>
           </a:xfrm>
           <a:prstGeom prst="rect">
             <a:avLst/>
@@ -3887,7 +4100,7 @@
       <p:grpSpPr/>
       <p:pic>
         <p:nvPicPr>
-          <p:cNvPr id="2" name="Picture 1" descr="11-conformitate.png"/>
+          <p:cNvPr id="2" name="Picture 1" descr="11-server.png"/>
           <p:cNvPicPr>
             <a:picLocks noChangeAspect="1"/>
           </p:cNvPicPr>
@@ -3902,7 +4115,7 @@
         <p:spPr>
           <a:xfrm>
             <a:off x="0" y="0"/>
-            <a:ext cx="12192000" cy="6858000"/>
+            <a:ext cx="12191695" cy="6858000"/>
           </a:xfrm>
           <a:prstGeom prst="rect">
             <a:avLst/>
@@ -3929,7 +4142,7 @@
       <p:grpSpPr/>
       <p:pic>
         <p:nvPicPr>
-          <p:cNvPr id="2" name="Picture 1" descr="12-pentru-cine.png"/>
+          <p:cNvPr id="2" name="Picture 1" descr="12-securitate.png"/>
           <p:cNvPicPr>
             <a:picLocks noChangeAspect="1"/>
           </p:cNvPicPr>
@@ -3944,7 +4157,7 @@
         <p:spPr>
           <a:xfrm>
             <a:off x="0" y="0"/>
-            <a:ext cx="12192000" cy="6858000"/>
+            <a:ext cx="12191695" cy="6858000"/>
           </a:xfrm>
           <a:prstGeom prst="rect">
             <a:avLst/>
@@ -3971,7 +4184,7 @@
       <p:grpSpPr/>
       <p:pic>
         <p:nvPicPr>
-          <p:cNvPr id="2" name="Picture 1" descr="13-stadiu.png"/>
+          <p:cNvPr id="2" name="Picture 1" descr="13-conformitate.png"/>
           <p:cNvPicPr>
             <a:picLocks noChangeAspect="1"/>
           </p:cNvPicPr>
@@ -3986,7 +4199,7 @@
         <p:spPr>
           <a:xfrm>
             <a:off x="0" y="0"/>
-            <a:ext cx="12192000" cy="6858000"/>
+            <a:ext cx="12191695" cy="6858000"/>
           </a:xfrm>
           <a:prstGeom prst="rect">
             <a:avLst/>
@@ -4013,7 +4226,7 @@
       <p:grpSpPr/>
       <p:pic>
         <p:nvPicPr>
-          <p:cNvPr id="2" name="Picture 1" descr="14-pasi.png"/>
+          <p:cNvPr id="2" name="Picture 1" descr="14-licenta.png"/>
           <p:cNvPicPr>
             <a:picLocks noChangeAspect="1"/>
           </p:cNvPicPr>
@@ -4028,7 +4241,133 @@
         <p:spPr>
           <a:xfrm>
             <a:off x="0" y="0"/>
-            <a:ext cx="12192000" cy="6858000"/>
+            <a:ext cx="12191695" cy="6858000"/>
+          </a:xfrm>
+          <a:prstGeom prst="rect">
+            <a:avLst/>
+          </a:prstGeom>
+        </p:spPr>
+      </p:pic>
+    </p:spTree>
+  </p:cSld>
+  <p:clrMapOvr>
+    <a:masterClrMapping/>
+  </p:clrMapOvr>
+</p:sld>
+</file>
+
+<file path=ppt/slides/slide15.xml><?xml version="1.0" encoding="utf-8"?>
+<p:sld xmlns:a="http://schemas.openxmlformats.org/drawingml/2006/main" xmlns:p="http://schemas.openxmlformats.org/presentationml/2006/main" xmlns:r="http://schemas.openxmlformats.org/officeDocument/2006/relationships">
+  <p:cSld>
+    <p:spTree>
+      <p:nvGrpSpPr>
+        <p:cNvPr id="1" name=""/>
+        <p:cNvGrpSpPr/>
+        <p:nvPr/>
+      </p:nvGrpSpPr>
+      <p:grpSpPr/>
+      <p:pic>
+        <p:nvPicPr>
+          <p:cNvPr id="2" name="Picture 1" descr="15-pentru-cine.png"/>
+          <p:cNvPicPr>
+            <a:picLocks noChangeAspect="1"/>
+          </p:cNvPicPr>
+          <p:nvPr/>
+        </p:nvPicPr>
+        <p:blipFill>
+          <a:blip r:embed="rId2"/>
+          <a:stretch>
+            <a:fillRect/>
+          </a:stretch>
+        </p:blipFill>
+        <p:spPr>
+          <a:xfrm>
+            <a:off x="0" y="0"/>
+            <a:ext cx="12191695" cy="6858000"/>
+          </a:xfrm>
+          <a:prstGeom prst="rect">
+            <a:avLst/>
+          </a:prstGeom>
+        </p:spPr>
+      </p:pic>
+    </p:spTree>
+  </p:cSld>
+  <p:clrMapOvr>
+    <a:masterClrMapping/>
+  </p:clrMapOvr>
+</p:sld>
+</file>
+
+<file path=ppt/slides/slide16.xml><?xml version="1.0" encoding="utf-8"?>
+<p:sld xmlns:a="http://schemas.openxmlformats.org/drawingml/2006/main" xmlns:p="http://schemas.openxmlformats.org/presentationml/2006/main" xmlns:r="http://schemas.openxmlformats.org/officeDocument/2006/relationships">
+  <p:cSld>
+    <p:spTree>
+      <p:nvGrpSpPr>
+        <p:cNvPr id="1" name=""/>
+        <p:cNvGrpSpPr/>
+        <p:nvPr/>
+      </p:nvGrpSpPr>
+      <p:grpSpPr/>
+      <p:pic>
+        <p:nvPicPr>
+          <p:cNvPr id="2" name="Picture 1" descr="16-stadiu.png"/>
+          <p:cNvPicPr>
+            <a:picLocks noChangeAspect="1"/>
+          </p:cNvPicPr>
+          <p:nvPr/>
+        </p:nvPicPr>
+        <p:blipFill>
+          <a:blip r:embed="rId2"/>
+          <a:stretch>
+            <a:fillRect/>
+          </a:stretch>
+        </p:blipFill>
+        <p:spPr>
+          <a:xfrm>
+            <a:off x="0" y="0"/>
+            <a:ext cx="12191695" cy="6858000"/>
+          </a:xfrm>
+          <a:prstGeom prst="rect">
+            <a:avLst/>
+          </a:prstGeom>
+        </p:spPr>
+      </p:pic>
+    </p:spTree>
+  </p:cSld>
+  <p:clrMapOvr>
+    <a:masterClrMapping/>
+  </p:clrMapOvr>
+</p:sld>
+</file>
+
+<file path=ppt/slides/slide17.xml><?xml version="1.0" encoding="utf-8"?>
+<p:sld xmlns:a="http://schemas.openxmlformats.org/drawingml/2006/main" xmlns:p="http://schemas.openxmlformats.org/presentationml/2006/main" xmlns:r="http://schemas.openxmlformats.org/officeDocument/2006/relationships">
+  <p:cSld>
+    <p:spTree>
+      <p:nvGrpSpPr>
+        <p:cNvPr id="1" name=""/>
+        <p:cNvGrpSpPr/>
+        <p:nvPr/>
+      </p:nvGrpSpPr>
+      <p:grpSpPr/>
+      <p:pic>
+        <p:nvPicPr>
+          <p:cNvPr id="2" name="Picture 1" descr="17-pasi.png"/>
+          <p:cNvPicPr>
+            <a:picLocks noChangeAspect="1"/>
+          </p:cNvPicPr>
+          <p:nvPr/>
+        </p:nvPicPr>
+        <p:blipFill>
+          <a:blip r:embed="rId2"/>
+          <a:stretch>
+            <a:fillRect/>
+          </a:stretch>
+        </p:blipFill>
+        <p:spPr>
+          <a:xfrm>
+            <a:off x="0" y="0"/>
+            <a:ext cx="12191695" cy="6858000"/>
           </a:xfrm>
           <a:prstGeom prst="rect">
             <a:avLst/>
@@ -4070,7 +4409,7 @@
         <p:spPr>
           <a:xfrm>
             <a:off x="0" y="0"/>
-            <a:ext cx="12192000" cy="6858000"/>
+            <a:ext cx="12191695" cy="6858000"/>
           </a:xfrm>
           <a:prstGeom prst="rect">
             <a:avLst/>
@@ -4112,7 +4451,7 @@
         <p:spPr>
           <a:xfrm>
             <a:off x="0" y="0"/>
-            <a:ext cx="12192000" cy="6858000"/>
+            <a:ext cx="12191695" cy="6858000"/>
           </a:xfrm>
           <a:prstGeom prst="rect">
             <a:avLst/>
@@ -4154,7 +4493,7 @@
         <p:spPr>
           <a:xfrm>
             <a:off x="0" y="0"/>
-            <a:ext cx="12192000" cy="6858000"/>
+            <a:ext cx="12191695" cy="6858000"/>
           </a:xfrm>
           <a:prstGeom prst="rect">
             <a:avLst/>
@@ -4196,7 +4535,7 @@
         <p:spPr>
           <a:xfrm>
             <a:off x="0" y="0"/>
-            <a:ext cx="12192000" cy="6858000"/>
+            <a:ext cx="12191695" cy="6858000"/>
           </a:xfrm>
           <a:prstGeom prst="rect">
             <a:avLst/>
@@ -4238,7 +4577,7 @@
         <p:spPr>
           <a:xfrm>
             <a:off x="0" y="0"/>
-            <a:ext cx="12192000" cy="6858000"/>
+            <a:ext cx="12191695" cy="6858000"/>
           </a:xfrm>
           <a:prstGeom prst="rect">
             <a:avLst/>
@@ -4280,7 +4619,7 @@
         <p:spPr>
           <a:xfrm>
             <a:off x="0" y="0"/>
-            <a:ext cx="12192000" cy="6858000"/>
+            <a:ext cx="12191695" cy="6858000"/>
           </a:xfrm>
           <a:prstGeom prst="rect">
             <a:avLst/>
@@ -4307,7 +4646,7 @@
       <p:grpSpPr/>
       <p:pic>
         <p:nvPicPr>
-          <p:cNvPr id="2" name="Picture 1" descr="08-ce-vede.png"/>
+          <p:cNvPr id="2" name="Picture 1" descr="08-rezilienta.png"/>
           <p:cNvPicPr>
             <a:picLocks noChangeAspect="1"/>
           </p:cNvPicPr>
@@ -4322,7 +4661,7 @@
         <p:spPr>
           <a:xfrm>
             <a:off x="0" y="0"/>
-            <a:ext cx="12192000" cy="6858000"/>
+            <a:ext cx="12191695" cy="6858000"/>
           </a:xfrm>
           <a:prstGeom prst="rect">
             <a:avLst/>
@@ -4349,7 +4688,7 @@
       <p:grpSpPr/>
       <p:pic>
         <p:nvPicPr>
-          <p:cNvPr id="2" name="Picture 1" descr="09-server.png"/>
+          <p:cNvPr id="2" name="Picture 1" descr="09-liste.png"/>
           <p:cNvPicPr>
             <a:picLocks noChangeAspect="1"/>
           </p:cNvPicPr>
@@ -4364,7 +4703,7 @@
         <p:spPr>
           <a:xfrm>
             <a:off x="0" y="0"/>
-            <a:ext cx="12192000" cy="6858000"/>
+            <a:ext cx="12191695" cy="6858000"/>
           </a:xfrm>
           <a:prstGeom prst="rect">
             <a:avLst/>

</xml_diff>

<commit_message>
Business deck: slide 'no phone number' (RO, DE), exports regenerated
Co-Authored-By: Claude Sonnet 5.5 <noreply@anthropic.com>
Claude-Session: https://claude.ai/code/session_01B6MtnqXxmaSfAE7RzqzhBD
</commit_message>
<xml_diff>
--- a/unpruuf/presentations/export/unpruuf_Business_DE.pptx
+++ b/unpruuf/presentations/export/unpruuf_Business_DE.pptx
@@ -22,6 +22,7 @@
     <p:sldId id="270" r:id="rId22"/>
     <p:sldId id="271" r:id="rId23"/>
     <p:sldId id="272" r:id="rId24"/>
+    <p:sldId id="273" r:id="rId25"/>
   </p:sldIdLst>
   <p:sldSz cx="12191695" cy="6858000" type="screen4x3"/>
   <p:notesSz cx="6858000" cy="9144000"/>
@@ -728,7 +729,7 @@
           <a:lstStyle/>
           <a:p>
             <a:r>
-              <a:t>Gemessen ohne Live-Tor-Netz: 500 Nodes in einem Prozess rund 85 MB RAM. Die Netzlast auf einem echten VPS ist noch nicht gemessen. 250 Kontakte gilt bei drei Servern mit je 250 Nodes, weil jeder Kontakt einen Node je Server bekommt.</a:t>
+              <a:t>In einem Atemzug: keine Telefonnummer, keine E-Mail. Ein Code pro Person. Kontakt löschen, und die Leitung ist weg. Dann die ehrliche Grenze: Was schon empfangen wurde, bleibt, und andere Kanäle sind unberührt. Nicht sagen, es sei ein Schutz vor allem.</a:t>
             </a:r>
           </a:p>
         </p:txBody>
@@ -798,7 +799,7 @@
           <a:lstStyle/>
           <a:p>
             <a:r>
-              <a:t>Die Empfehlung drei Anbieter, zwei Länder ist Sache des Kunden: Die App kann nicht prüfen, ob drei Server beim selben Hoster liegen. Nach einem Neustart ist jeder Server gesperrt, bis die App ihn freigibt. Solange einer gesperrt ist, tragen die anderen.</a:t>
+              <a:t>Gemessen ohne Live-Tor-Netz: 500 Nodes in einem Prozess rund 85 MB RAM. Die Netzlast auf einem echten VPS ist noch nicht gemessen. 250 Kontakte gilt bei drei Servern mit je 250 Nodes, weil jeder Kontakt einen Node je Server bekommt.</a:t>
             </a:r>
           </a:p>
         </p:txBody>
@@ -868,7 +869,7 @@
           <a:lstStyle/>
           <a:p>
             <a:r>
-              <a:t>Eine Liste mit nur einem Server legt alle drei Nodes eines Kontakts auf dieselbe Maschine. Deshalb mehrere Server in eine Liste legen.</a:t>
+              <a:t>Die Empfehlung drei Anbieter, zwei Länder ist Sache des Kunden: Die App kann nicht prüfen, ob drei Server beim selben Hoster liegen. Nach einem Neustart ist jeder Server gesperrt, bis die App ihn freigibt. Solange einer gesperrt ist, tragen die anderen.</a:t>
             </a:r>
           </a:p>
         </p:txBody>
@@ -938,7 +939,7 @@
           <a:lstStyle/>
           <a:p>
             <a:r>
-              <a:t>Vorsichtig formulieren: Wir sagen nicht, dass Durchsuchungen oder Anordnungen sinnlos sind. Wir sagen, dass es keinen Anbieter gibt, der etwas herausgeben könnte, und dass ein beschlagnahmter Node nichts Lesbares enthält. Rechtliche Einschätzung durch einen Anwalt bestätigen lassen.</a:t>
+              <a:t>Eine Liste mit nur einem Server legt alle drei Nodes eines Kontakts auf dieselbe Maschine. Deshalb mehrere Server in eine Liste legen.</a:t>
             </a:r>
           </a:p>
         </p:txBody>
@@ -964,6 +965,76 @@
 </file>
 
 <file path=ppt/notesSlides/notesSlide8.xml><?xml version="1.0" encoding="utf-8"?>
+<p:notes xmlns:a="http://schemas.openxmlformats.org/drawingml/2006/main" xmlns:p="http://schemas.openxmlformats.org/presentationml/2006/main" xmlns:r="http://schemas.openxmlformats.org/officeDocument/2006/relationships">
+  <p:cSld>
+    <p:spTree>
+      <p:nvGrpSpPr>
+        <p:cNvPr id="1" name=""/>
+        <p:cNvGrpSpPr/>
+        <p:nvPr/>
+      </p:nvGrpSpPr>
+      <p:grpSpPr>
+        <a:xfrm>
+          <a:off x="0" y="0"/>
+          <a:ext cx="0" cy="0"/>
+          <a:chOff x="0" y="0"/>
+          <a:chExt cx="0" cy="0"/>
+        </a:xfrm>
+      </p:grpSpPr>
+      <p:sp>
+        <p:nvSpPr>
+          <p:cNvPr id="2" name="Slide Image Placeholder 1"/>
+          <p:cNvSpPr>
+            <a:spLocks noGrp="1"/>
+          </p:cNvSpPr>
+          <p:nvPr>
+            <p:ph type="sldImg" idx="2"/>
+          </p:nvPr>
+        </p:nvSpPr>
+        <p:spPr/>
+      </p:sp>
+      <p:sp>
+        <p:nvSpPr>
+          <p:cNvPr id="3" name="Notes Placeholder 2"/>
+          <p:cNvSpPr>
+            <a:spLocks noGrp="1"/>
+          </p:cNvSpPr>
+          <p:nvPr>
+            <p:ph type="body" idx="3" sz="quarter"/>
+          </p:nvPr>
+        </p:nvSpPr>
+        <p:spPr/>
+        <p:txBody>
+          <a:bodyPr/>
+          <a:lstStyle/>
+          <a:p>
+            <a:r>
+              <a:t>Vorsichtig formulieren: Wir sagen nicht, dass Durchsuchungen oder Anordnungen sinnlos sind. Wir sagen, dass es keinen Anbieter gibt, der etwas herausgeben könnte, und dass ein beschlagnahmter Node nichts Lesbares enthält. Rechtliche Einschätzung durch einen Anwalt bestätigen lassen.</a:t>
+            </a:r>
+          </a:p>
+        </p:txBody>
+      </p:sp>
+      <p:sp>
+        <p:nvSpPr>
+          <p:cNvPr id="4" name="Slide Number Placeholder 3"/>
+          <p:cNvSpPr>
+            <a:spLocks noGrp="1"/>
+          </p:cNvSpPr>
+          <p:nvPr>
+            <p:ph type="sldNum" idx="5" sz="quarter"/>
+          </p:nvPr>
+        </p:nvSpPr>
+        <p:spPr/>
+      </p:sp>
+    </p:spTree>
+  </p:cSld>
+  <p:clrMapOvr>
+    <a:masterClrMapping/>
+  </p:clrMapOvr>
+</p:notes>
+</file>
+
+<file path=ppt/notesSlides/notesSlide9.xml><?xml version="1.0" encoding="utf-8"?>
 <p:notes xmlns:a="http://schemas.openxmlformats.org/drawingml/2006/main" xmlns:p="http://schemas.openxmlformats.org/presentationml/2006/main" xmlns:r="http://schemas.openxmlformats.org/officeDocument/2006/relationships">
   <p:cSld>
     <p:spTree>
@@ -4058,7 +4129,7 @@
       <p:grpSpPr/>
       <p:pic>
         <p:nvPicPr>
-          <p:cNvPr id="2" name="Picture 1" descr="10-ce-vede.png"/>
+          <p:cNvPr id="2" name="Picture 1" descr="10-liste.png"/>
           <p:cNvPicPr>
             <a:picLocks noChangeAspect="1"/>
           </p:cNvPicPr>
@@ -4100,7 +4171,7 @@
       <p:grpSpPr/>
       <p:pic>
         <p:nvPicPr>
-          <p:cNvPr id="2" name="Picture 1" descr="11-server.png"/>
+          <p:cNvPr id="2" name="Picture 1" descr="11-ce-vede.png"/>
           <p:cNvPicPr>
             <a:picLocks noChangeAspect="1"/>
           </p:cNvPicPr>
@@ -4142,7 +4213,7 @@
       <p:grpSpPr/>
       <p:pic>
         <p:nvPicPr>
-          <p:cNvPr id="2" name="Picture 1" descr="12-securitate.png"/>
+          <p:cNvPr id="2" name="Picture 1" descr="12-server.png"/>
           <p:cNvPicPr>
             <a:picLocks noChangeAspect="1"/>
           </p:cNvPicPr>
@@ -4184,7 +4255,7 @@
       <p:grpSpPr/>
       <p:pic>
         <p:nvPicPr>
-          <p:cNvPr id="2" name="Picture 1" descr="13-conformitate.png"/>
+          <p:cNvPr id="2" name="Picture 1" descr="13-securitate.png"/>
           <p:cNvPicPr>
             <a:picLocks noChangeAspect="1"/>
           </p:cNvPicPr>
@@ -4226,7 +4297,7 @@
       <p:grpSpPr/>
       <p:pic>
         <p:nvPicPr>
-          <p:cNvPr id="2" name="Picture 1" descr="14-licenta.png"/>
+          <p:cNvPr id="2" name="Picture 1" descr="14-conformitate.png"/>
           <p:cNvPicPr>
             <a:picLocks noChangeAspect="1"/>
           </p:cNvPicPr>
@@ -4268,7 +4339,7 @@
       <p:grpSpPr/>
       <p:pic>
         <p:nvPicPr>
-          <p:cNvPr id="2" name="Picture 1" descr="15-pentru-cine.png"/>
+          <p:cNvPr id="2" name="Picture 1" descr="15-licenta.png"/>
           <p:cNvPicPr>
             <a:picLocks noChangeAspect="1"/>
           </p:cNvPicPr>
@@ -4310,7 +4381,7 @@
       <p:grpSpPr/>
       <p:pic>
         <p:nvPicPr>
-          <p:cNvPr id="2" name="Picture 1" descr="16-stadiu.png"/>
+          <p:cNvPr id="2" name="Picture 1" descr="16-pentru-cine.png"/>
           <p:cNvPicPr>
             <a:picLocks noChangeAspect="1"/>
           </p:cNvPicPr>
@@ -4352,7 +4423,49 @@
       <p:grpSpPr/>
       <p:pic>
         <p:nvPicPr>
-          <p:cNvPr id="2" name="Picture 1" descr="17-pasi.png"/>
+          <p:cNvPr id="2" name="Picture 1" descr="17-stadiu.png"/>
+          <p:cNvPicPr>
+            <a:picLocks noChangeAspect="1"/>
+          </p:cNvPicPr>
+          <p:nvPr/>
+        </p:nvPicPr>
+        <p:blipFill>
+          <a:blip r:embed="rId2"/>
+          <a:stretch>
+            <a:fillRect/>
+          </a:stretch>
+        </p:blipFill>
+        <p:spPr>
+          <a:xfrm>
+            <a:off x="0" y="0"/>
+            <a:ext cx="12191695" cy="6858000"/>
+          </a:xfrm>
+          <a:prstGeom prst="rect">
+            <a:avLst/>
+          </a:prstGeom>
+        </p:spPr>
+      </p:pic>
+    </p:spTree>
+  </p:cSld>
+  <p:clrMapOvr>
+    <a:masterClrMapping/>
+  </p:clrMapOvr>
+</p:sld>
+</file>
+
+<file path=ppt/slides/slide18.xml><?xml version="1.0" encoding="utf-8"?>
+<p:sld xmlns:a="http://schemas.openxmlformats.org/drawingml/2006/main" xmlns:p="http://schemas.openxmlformats.org/presentationml/2006/main" xmlns:r="http://schemas.openxmlformats.org/officeDocument/2006/relationships">
+  <p:cSld>
+    <p:spTree>
+      <p:nvGrpSpPr>
+        <p:cNvPr id="1" name=""/>
+        <p:cNvGrpSpPr/>
+        <p:nvPr/>
+      </p:nvGrpSpPr>
+      <p:grpSpPr/>
+      <p:pic>
+        <p:nvPicPr>
+          <p:cNvPr id="2" name="Picture 1" descr="18-pasi.png"/>
           <p:cNvPicPr>
             <a:picLocks noChangeAspect="1"/>
           </p:cNvPicPr>
@@ -4604,7 +4717,7 @@
       <p:grpSpPr/>
       <p:pic>
         <p:nvPicPr>
-          <p:cNvPr id="2" name="Picture 1" descr="07-sute-noduri.png"/>
+          <p:cNvPr id="2" name="Picture 1" descr="07-fara-numar.png"/>
           <p:cNvPicPr>
             <a:picLocks noChangeAspect="1"/>
           </p:cNvPicPr>
@@ -4646,7 +4759,7 @@
       <p:grpSpPr/>
       <p:pic>
         <p:nvPicPr>
-          <p:cNvPr id="2" name="Picture 1" descr="08-rezilienta.png"/>
+          <p:cNvPr id="2" name="Picture 1" descr="08-sute-noduri.png"/>
           <p:cNvPicPr>
             <a:picLocks noChangeAspect="1"/>
           </p:cNvPicPr>
@@ -4688,7 +4801,7 @@
       <p:grpSpPr/>
       <p:pic>
         <p:nvPicPr>
-          <p:cNvPr id="2" name="Picture 1" descr="09-liste.png"/>
+          <p:cNvPr id="2" name="Picture 1" descr="09-rezilienta.png"/>
           <p:cNvPicPr>
             <a:picLocks noChangeAspect="1"/>
           </p:cNvPicPr>

</xml_diff>